<commit_message>
fix(deck): wish-I'd-known numerals clipped — only "0" of "01/02/03/04" rendered
Visual QA via Keynote → PDF → pdftoppm caught it: fontSize 220 in a 3.5"
text box overflowed the right edge so the second digit was cut off on
slides 6, 7, 8, 9 — the central design feature of those slides was broken.

Reduced font to 180 and widened the numeral box to 4.3" (with the right
column shifted to x:5.0, w:4.5). Both digits now render cleanly; body
text in the right column wraps naturally within the new width.

Co-Authored-By: Claude Opus 4.7 (1M context) <noreply@anthropic.com>
</commit_message>
<xml_diff>
--- a/deliverables/internship-return/internship-return-day.pptx
+++ b/deliverables/internship-return/internship-return-day.pptx
@@ -4808,7 +4808,7 @@
         <p:spPr>
           <a:xfrm>
             <a:off x="502920" y="1005840"/>
-            <a:ext cx="3200400" cy="3383280"/>
+            <a:ext cx="3931920" cy="3383280"/>
           </a:xfrm>
           <a:prstGeom prst="rect">
             <a:avLst/>
@@ -4820,11 +4820,11 @@
           <a:bodyPr wrap="square" lIns="0" tIns="0" rIns="0" bIns="0" rtlCol="0" anchor="t"/>
           <a:lstStyle/>
           <a:p>
-            <a:pPr indent="0" marL="0">
-              <a:buNone/>
-            </a:pPr>
-            <a:r>
-              <a:rPr lang="en-US" sz="22000" b="1" dirty="0">
+            <a:pPr algn="l" indent="0" marL="0">
+              <a:buNone/>
+            </a:pPr>
+            <a:r>
+              <a:rPr lang="en-US" sz="18000" b="1" dirty="0">
                 <a:solidFill>
                   <a:srgbClr val="D4A843"/>
                 </a:solidFill>
@@ -4834,7 +4834,7 @@
               </a:rPr>
               <a:t>01</a:t>
             </a:r>
-            <a:endParaRPr lang="en-US" sz="22000" dirty="0"/>
+            <a:endParaRPr lang="en-US" sz="18000" dirty="0"/>
           </a:p>
         </p:txBody>
       </p:sp>
@@ -4846,8 +4846,8 @@
         </p:nvSpPr>
         <p:spPr>
           <a:xfrm>
-            <a:off x="3840480" y="1554480"/>
-            <a:ext cx="4754880" cy="1371600"/>
+            <a:off x="4572000" y="1554480"/>
+            <a:ext cx="4114800" cy="1371600"/>
           </a:xfrm>
           <a:prstGeom prst="rect">
             <a:avLst/>
@@ -4863,7 +4863,7 @@
               <a:buNone/>
             </a:pPr>
             <a:r>
-              <a:rPr lang="en-US" sz="2800" b="1" dirty="0">
+              <a:rPr lang="en-US" sz="2600" b="1" dirty="0">
                 <a:solidFill>
                   <a:srgbClr val="2D1B1A"/>
                 </a:solidFill>
@@ -4873,7 +4873,7 @@
               </a:rPr>
               <a:t>Pick where you can ship, not where you can observe.</a:t>
             </a:r>
-            <a:endParaRPr lang="en-US" sz="2800" dirty="0"/>
+            <a:endParaRPr lang="en-US" sz="2600" dirty="0"/>
           </a:p>
         </p:txBody>
       </p:sp>
@@ -4885,8 +4885,8 @@
         </p:nvSpPr>
         <p:spPr>
           <a:xfrm>
-            <a:off x="3840480" y="2926080"/>
-            <a:ext cx="4754880" cy="1554480"/>
+            <a:off x="4572000" y="2926080"/>
+            <a:ext cx="4114800" cy="1554480"/>
           </a:xfrm>
           <a:prstGeom prst="rect">
             <a:avLst/>
@@ -4902,7 +4902,7 @@
               <a:buNone/>
             </a:pPr>
             <a:r>
-              <a:rPr lang="en-US" sz="1500" dirty="0">
+              <a:rPr lang="en-US" sz="1400" dirty="0">
                 <a:solidFill>
                   <a:srgbClr val="7A4F47"/>
                 </a:solidFill>
@@ -4912,7 +4912,7 @@
               </a:rPr>
               <a:t>A small or distant company will hand you the keys on week one. A big-brand agency will ask you to assist. For your CMD portfolio, ownership beats prestige. The work you do is the only thing the report can be about — pick a place that lets you actually do some.</a:t>
             </a:r>
-            <a:endParaRPr lang="en-US" sz="1500" dirty="0"/>
+            <a:endParaRPr lang="en-US" sz="1400" dirty="0"/>
           </a:p>
         </p:txBody>
       </p:sp>
@@ -5122,7 +5122,7 @@
         <p:spPr>
           <a:xfrm>
             <a:off x="502920" y="1005840"/>
-            <a:ext cx="3200400" cy="3383280"/>
+            <a:ext cx="3931920" cy="3383280"/>
           </a:xfrm>
           <a:prstGeom prst="rect">
             <a:avLst/>
@@ -5134,11 +5134,11 @@
           <a:bodyPr wrap="square" lIns="0" tIns="0" rIns="0" bIns="0" rtlCol="0" anchor="t"/>
           <a:lstStyle/>
           <a:p>
-            <a:pPr indent="0" marL="0">
-              <a:buNone/>
-            </a:pPr>
-            <a:r>
-              <a:rPr lang="en-US" sz="22000" b="1" dirty="0">
+            <a:pPr algn="l" indent="0" marL="0">
+              <a:buNone/>
+            </a:pPr>
+            <a:r>
+              <a:rPr lang="en-US" sz="18000" b="1" dirty="0">
                 <a:solidFill>
                   <a:srgbClr val="D4A843"/>
                 </a:solidFill>
@@ -5148,7 +5148,7 @@
               </a:rPr>
               <a:t>02</a:t>
             </a:r>
-            <a:endParaRPr lang="en-US" sz="22000" dirty="0"/>
+            <a:endParaRPr lang="en-US" sz="18000" dirty="0"/>
           </a:p>
         </p:txBody>
       </p:sp>
@@ -5160,8 +5160,8 @@
         </p:nvSpPr>
         <p:spPr>
           <a:xfrm>
-            <a:off x="3840480" y="1554480"/>
-            <a:ext cx="4754880" cy="1371600"/>
+            <a:off x="4572000" y="1554480"/>
+            <a:ext cx="4114800" cy="1371600"/>
           </a:xfrm>
           <a:prstGeom prst="rect">
             <a:avLst/>
@@ -5177,7 +5177,7 @@
               <a:buNone/>
             </a:pPr>
             <a:r>
-              <a:rPr lang="en-US" sz="2800" b="1" dirty="0">
+              <a:rPr lang="en-US" sz="2600" b="1" dirty="0">
                 <a:solidFill>
                   <a:srgbClr val="2D1B1A"/>
                 </a:solidFill>
@@ -5187,7 +5187,7 @@
               </a:rPr>
               <a:t>If the brief is ambiguous, that's the gift.</a:t>
             </a:r>
-            <a:endParaRPr lang="en-US" sz="2800" dirty="0"/>
+            <a:endParaRPr lang="en-US" sz="2600" dirty="0"/>
           </a:p>
         </p:txBody>
       </p:sp>
@@ -5199,8 +5199,8 @@
         </p:nvSpPr>
         <p:spPr>
           <a:xfrm>
-            <a:off x="3840480" y="2926080"/>
-            <a:ext cx="4754880" cy="1554480"/>
+            <a:off x="4572000" y="2926080"/>
+            <a:ext cx="4114800" cy="1554480"/>
           </a:xfrm>
           <a:prstGeom prst="rect">
             <a:avLst/>
@@ -5216,7 +5216,7 @@
               <a:buNone/>
             </a:pPr>
             <a:r>
-              <a:rPr lang="en-US" sz="1500" dirty="0">
+              <a:rPr lang="en-US" sz="1400" dirty="0">
                 <a:solidFill>
                   <a:srgbClr val="7A4F47"/>
                 </a:solidFill>
@@ -5226,7 +5226,7 @@
               </a:rPr>
               <a:t>My brief on day one was three lines. It scared me at first. By week three I realised the open-endedness was the most valuable thing my supervisor could have given me — every scoping decision was mine to make, every piece of work was mine to own. Don't try to get the brief locked down before you start. Get good at scoping.</a:t>
             </a:r>
-            <a:endParaRPr lang="en-US" sz="1500" dirty="0"/>
+            <a:endParaRPr lang="en-US" sz="1400" dirty="0"/>
           </a:p>
         </p:txBody>
       </p:sp>
@@ -5436,7 +5436,7 @@
         <p:spPr>
           <a:xfrm>
             <a:off x="502920" y="1005840"/>
-            <a:ext cx="3200400" cy="3383280"/>
+            <a:ext cx="3931920" cy="3383280"/>
           </a:xfrm>
           <a:prstGeom prst="rect">
             <a:avLst/>
@@ -5448,11 +5448,11 @@
           <a:bodyPr wrap="square" lIns="0" tIns="0" rIns="0" bIns="0" rtlCol="0" anchor="t"/>
           <a:lstStyle/>
           <a:p>
-            <a:pPr indent="0" marL="0">
-              <a:buNone/>
-            </a:pPr>
-            <a:r>
-              <a:rPr lang="en-US" sz="22000" b="1" dirty="0">
+            <a:pPr algn="l" indent="0" marL="0">
+              <a:buNone/>
+            </a:pPr>
+            <a:r>
+              <a:rPr lang="en-US" sz="18000" b="1" dirty="0">
                 <a:solidFill>
                   <a:srgbClr val="D4A843"/>
                 </a:solidFill>
@@ -5462,7 +5462,7 @@
               </a:rPr>
               <a:t>03</a:t>
             </a:r>
-            <a:endParaRPr lang="en-US" sz="22000" dirty="0"/>
+            <a:endParaRPr lang="en-US" sz="18000" dirty="0"/>
           </a:p>
         </p:txBody>
       </p:sp>
@@ -5474,8 +5474,8 @@
         </p:nvSpPr>
         <p:spPr>
           <a:xfrm>
-            <a:off x="3840480" y="1554480"/>
-            <a:ext cx="4754880" cy="1371600"/>
+            <a:off x="4572000" y="1554480"/>
+            <a:ext cx="4114800" cy="1371600"/>
           </a:xfrm>
           <a:prstGeom prst="rect">
             <a:avLst/>
@@ -5491,7 +5491,7 @@
               <a:buNone/>
             </a:pPr>
             <a:r>
-              <a:rPr lang="en-US" sz="2800" b="1" dirty="0">
+              <a:rPr lang="en-US" sz="2600" b="1" dirty="0">
                 <a:solidFill>
                   <a:srgbClr val="2D1B1A"/>
                 </a:solidFill>
@@ -5501,7 +5501,7 @@
               </a:rPr>
               <a:t>Your competences are broader than "design".</a:t>
             </a:r>
-            <a:endParaRPr lang="en-US" sz="2800" dirty="0"/>
+            <a:endParaRPr lang="en-US" sz="2600" dirty="0"/>
           </a:p>
         </p:txBody>
       </p:sp>
@@ -5513,8 +5513,8 @@
         </p:nvSpPr>
         <p:spPr>
           <a:xfrm>
-            <a:off x="3840480" y="2926080"/>
-            <a:ext cx="4754880" cy="1554480"/>
+            <a:off x="4572000" y="2926080"/>
+            <a:ext cx="4114800" cy="1554480"/>
           </a:xfrm>
           <a:prstGeom prst="rect">
             <a:avLst/>
@@ -5530,7 +5530,7 @@
               <a:buNone/>
             </a:pPr>
             <a:r>
-              <a:rPr lang="en-US" sz="1500" dirty="0">
+              <a:rPr lang="en-US" sz="1400" dirty="0">
                 <a:solidFill>
                   <a:srgbClr val="7A4F47"/>
                 </a:solidFill>
@@ -5540,7 +5540,7 @@
               </a:rPr>
               <a:t>I shipped UX flows. I also shipped system architecture, a 42-page research report, four payment integrations, and a live demo to company leadership. Every one of those mapped to an HBO-i competence. CMD's framework is broader than visual design — let the work be too.</a:t>
             </a:r>
-            <a:endParaRPr lang="en-US" sz="1500" dirty="0"/>
+            <a:endParaRPr lang="en-US" sz="1400" dirty="0"/>
           </a:p>
         </p:txBody>
       </p:sp>
@@ -5750,7 +5750,7 @@
         <p:spPr>
           <a:xfrm>
             <a:off x="502920" y="1005840"/>
-            <a:ext cx="3200400" cy="3383280"/>
+            <a:ext cx="3931920" cy="3383280"/>
           </a:xfrm>
           <a:prstGeom prst="rect">
             <a:avLst/>
@@ -5762,11 +5762,11 @@
           <a:bodyPr wrap="square" lIns="0" tIns="0" rIns="0" bIns="0" rtlCol="0" anchor="t"/>
           <a:lstStyle/>
           <a:p>
-            <a:pPr indent="0" marL="0">
-              <a:buNone/>
-            </a:pPr>
-            <a:r>
-              <a:rPr lang="en-US" sz="22000" b="1" dirty="0">
+            <a:pPr algn="l" indent="0" marL="0">
+              <a:buNone/>
+            </a:pPr>
+            <a:r>
+              <a:rPr lang="en-US" sz="18000" b="1" dirty="0">
                 <a:solidFill>
                   <a:srgbClr val="D4A843"/>
                 </a:solidFill>
@@ -5776,7 +5776,7 @@
               </a:rPr>
               <a:t>04</a:t>
             </a:r>
-            <a:endParaRPr lang="en-US" sz="22000" dirty="0"/>
+            <a:endParaRPr lang="en-US" sz="18000" dirty="0"/>
           </a:p>
         </p:txBody>
       </p:sp>
@@ -5788,8 +5788,8 @@
         </p:nvSpPr>
         <p:spPr>
           <a:xfrm>
-            <a:off x="3840480" y="1554480"/>
-            <a:ext cx="4754880" cy="1371600"/>
+            <a:off x="4572000" y="1554480"/>
+            <a:ext cx="4114800" cy="1371600"/>
           </a:xfrm>
           <a:prstGeom prst="rect">
             <a:avLst/>
@@ -5805,7 +5805,7 @@
               <a:buNone/>
             </a:pPr>
             <a:r>
-              <a:rPr lang="en-US" sz="2800" b="1" dirty="0">
+              <a:rPr lang="en-US" sz="2600" b="1" dirty="0">
                 <a:solidFill>
                   <a:srgbClr val="2D1B1A"/>
                 </a:solidFill>
@@ -5815,7 +5815,7 @@
               </a:rPr>
               <a:t>Start writing the report in week one.</a:t>
             </a:r>
-            <a:endParaRPr lang="en-US" sz="2800" dirty="0"/>
+            <a:endParaRPr lang="en-US" sz="2600" dirty="0"/>
           </a:p>
         </p:txBody>
       </p:sp>
@@ -5827,8 +5827,8 @@
         </p:nvSpPr>
         <p:spPr>
           <a:xfrm>
-            <a:off x="3840480" y="2926080"/>
-            <a:ext cx="4754880" cy="1554480"/>
+            <a:off x="4572000" y="2926080"/>
+            <a:ext cx="4114800" cy="1554480"/>
           </a:xfrm>
           <a:prstGeom prst="rect">
             <a:avLst/>
@@ -5844,7 +5844,7 @@
               <a:buNone/>
             </a:pPr>
             <a:r>
-              <a:rPr lang="en-US" sz="1500" dirty="0">
+              <a:rPr lang="en-US" sz="1400" dirty="0">
                 <a:solidFill>
                   <a:srgbClr val="7A4F47"/>
                 </a:solidFill>
@@ -5854,7 +5854,7 @@
               </a:rPr>
               <a:t>Everyone tells you this. Everyone ignores it. Don't. Half my deliverables exist *because* I wrote them down weekly — not because I sat down at week 18 and tried to remember what happened. Treat the report as a journal you write towards, not a deliverable you write at the end.</a:t>
             </a:r>
-            <a:endParaRPr lang="en-US" sz="1500" dirty="0"/>
+            <a:endParaRPr lang="en-US" sz="1400" dirty="0"/>
           </a:p>
         </p:txBody>
       </p:sp>

</xml_diff>

<commit_message>
docs(deck): add MD reframe to slide 4 — "build software you can sell"
The project's commercial intent is the load-bearing context for everything
that follows in the deck. Slide 4 now leads with: ZimLivestock as software
built to be sold to Zimbabwean auction houses, and an italic pull-quote
attributing the framing to the Paynow MD.

Output cards compressed slightly (h: 2.0 → 1.75) to make room. Quote sits
in a 1-line treatment at y: 4.7 with terracotta curly marks on either side.
Speaker script for slide 4 updated to match (~55s instead of 45s).

Co-Authored-By: Claude Opus 4.7 (1M context) <noreply@anthropic.com>
</commit_message>
<xml_diff>
--- a/deliverables/internship-return/internship-return-day.pptx
+++ b/deliverables/internship-return/internship-return-day.pptx
@@ -3593,7 +3593,7 @@
         <p:spPr>
           <a:xfrm>
             <a:off x="640080" y="868680"/>
-            <a:ext cx="7863840" cy="640080"/>
+            <a:ext cx="7863840" cy="594360"/>
           </a:xfrm>
           <a:prstGeom prst="rect">
             <a:avLst/>
@@ -3631,8 +3631,8 @@
         </p:nvSpPr>
         <p:spPr>
           <a:xfrm>
-            <a:off x="640080" y="1417320"/>
-            <a:ext cx="7863840" cy="731520"/>
+            <a:off x="640080" y="1371600"/>
+            <a:ext cx="7863840" cy="685800"/>
           </a:xfrm>
           <a:prstGeom prst="rect">
             <a:avLst/>
@@ -3656,7 +3656,7 @@
                 <a:ea typeface="Calibri" pitchFamily="34" charset="-122"/>
                 <a:cs typeface="Calibri" pitchFamily="34" charset="-120"/>
               </a:rPr>
-              <a:t>a marketplace for cattle, goats, and sheep, running on every product in Paynow's ecosystem.</a:t>
+              <a:t>software built to be sold to Zimbabwean auction houses, running on every product in Paynow's ecosystem.</a:t>
             </a:r>
             <a:endParaRPr lang="en-US" sz="1600" dirty="0"/>
           </a:p>
@@ -3670,8 +3670,8 @@
         </p:nvSpPr>
         <p:spPr>
           <a:xfrm>
-            <a:off x="640080" y="2651760"/>
-            <a:ext cx="3931920" cy="1828800"/>
+            <a:off x="640080" y="2468880"/>
+            <a:ext cx="3931920" cy="1600200"/>
           </a:xfrm>
           <a:prstGeom prst="rect">
             <a:avLst/>
@@ -3690,8 +3690,8 @@
         </p:nvSpPr>
         <p:spPr>
           <a:xfrm>
-            <a:off x="640080" y="2651760"/>
-            <a:ext cx="73152" cy="1828800"/>
+            <a:off x="640080" y="2468880"/>
+            <a:ext cx="73152" cy="1600200"/>
           </a:xfrm>
           <a:prstGeom prst="rect">
             <a:avLst/>
@@ -3710,7 +3710,7 @@
         </p:nvSpPr>
         <p:spPr>
           <a:xfrm>
-            <a:off x="868680" y="2788920"/>
+            <a:off x="868680" y="2578608"/>
             <a:ext cx="3657600" cy="274320"/>
           </a:xfrm>
           <a:prstGeom prst="rect">
@@ -3749,8 +3749,8 @@
         </p:nvSpPr>
         <p:spPr>
           <a:xfrm>
-            <a:off x="868680" y="3108960"/>
-            <a:ext cx="3657600" cy="457200"/>
+            <a:off x="868680" y="2880360"/>
+            <a:ext cx="3657600" cy="411480"/>
           </a:xfrm>
           <a:prstGeom prst="rect">
             <a:avLst/>
@@ -3788,8 +3788,8 @@
         </p:nvSpPr>
         <p:spPr>
           <a:xfrm>
-            <a:off x="868680" y="3611880"/>
-            <a:ext cx="3657600" cy="777240"/>
+            <a:off x="868680" y="3337560"/>
+            <a:ext cx="3657600" cy="713232"/>
           </a:xfrm>
           <a:prstGeom prst="rect">
             <a:avLst/>
@@ -3827,8 +3827,8 @@
         </p:nvSpPr>
         <p:spPr>
           <a:xfrm>
-            <a:off x="4800600" y="2651760"/>
-            <a:ext cx="3931920" cy="1828800"/>
+            <a:off x="4800600" y="2468880"/>
+            <a:ext cx="3931920" cy="1600200"/>
           </a:xfrm>
           <a:prstGeom prst="rect">
             <a:avLst/>
@@ -3847,8 +3847,8 @@
         </p:nvSpPr>
         <p:spPr>
           <a:xfrm>
-            <a:off x="4800600" y="2651760"/>
-            <a:ext cx="73152" cy="1828800"/>
+            <a:off x="4800600" y="2468880"/>
+            <a:ext cx="73152" cy="1600200"/>
           </a:xfrm>
           <a:prstGeom prst="rect">
             <a:avLst/>
@@ -3867,7 +3867,7 @@
         </p:nvSpPr>
         <p:spPr>
           <a:xfrm>
-            <a:off x="5029200" y="2788920"/>
+            <a:off x="5029200" y="2578608"/>
             <a:ext cx="3657600" cy="274320"/>
           </a:xfrm>
           <a:prstGeom prst="rect">
@@ -3906,8 +3906,8 @@
         </p:nvSpPr>
         <p:spPr>
           <a:xfrm>
-            <a:off x="5029200" y="3108960"/>
-            <a:ext cx="3657600" cy="457200"/>
+            <a:off x="5029200" y="2880360"/>
+            <a:ext cx="3657600" cy="411480"/>
           </a:xfrm>
           <a:prstGeom prst="rect">
             <a:avLst/>
@@ -3945,8 +3945,8 @@
         </p:nvSpPr>
         <p:spPr>
           <a:xfrm>
-            <a:off x="5029200" y="3611880"/>
-            <a:ext cx="3657600" cy="777240"/>
+            <a:off x="5029200" y="3337560"/>
+            <a:ext cx="3657600" cy="713232"/>
           </a:xfrm>
           <a:prstGeom prst="rect">
             <a:avLst/>
@@ -3979,6 +3979,87 @@
       <p:sp>
         <p:nvSpPr>
           <p:cNvPr id="16" name="Text 14"/>
+          <p:cNvSpPr/>
+          <p:nvPr/>
+        </p:nvSpPr>
+        <p:spPr>
+          <a:xfrm>
+            <a:off x="640080" y="4297680"/>
+            <a:ext cx="7863840" cy="365760"/>
+          </a:xfrm>
+          <a:prstGeom prst="rect">
+            <a:avLst/>
+          </a:prstGeom>
+          <a:noFill/>
+          <a:ln/>
+        </p:spPr>
+        <p:txBody>
+          <a:bodyPr wrap="square" lIns="0" tIns="0" rIns="0" bIns="0" rtlCol="0" anchor="ctr"/>
+          <a:lstStyle/>
+          <a:p>
+            <a:pPr indent="0" marL="0">
+              <a:buNone/>
+            </a:pPr>
+            <a:r>
+              <a:rPr lang="en-US" sz="2200" b="1" dirty="0">
+                <a:solidFill>
+                  <a:srgbClr val="B85042"/>
+                </a:solidFill>
+                <a:latin typeface="Georgia" pitchFamily="34" charset="0"/>
+                <a:ea typeface="Georgia" pitchFamily="34" charset="-122"/>
+                <a:cs typeface="Georgia" pitchFamily="34" charset="-120"/>
+              </a:rPr>
+              <a:t>“</a:t>
+            </a:r>
+            <a:pPr indent="0" marL="0">
+              <a:buNone/>
+            </a:pPr>
+            <a:r>
+              <a:rPr lang="en-US" sz="1400" i="1" dirty="0">
+                <a:solidFill>
+                  <a:srgbClr val="2D1B1A"/>
+                </a:solidFill>
+                <a:latin typeface="Georgia" pitchFamily="34" charset="0"/>
+                <a:ea typeface="Georgia" pitchFamily="34" charset="-122"/>
+                <a:cs typeface="Georgia" pitchFamily="34" charset="-120"/>
+              </a:rPr>
+              <a:t>Don't build a thesis. Build software you can sell.</a:t>
+            </a:r>
+            <a:pPr indent="0" marL="0">
+              <a:buNone/>
+            </a:pPr>
+            <a:r>
+              <a:rPr lang="en-US" sz="2200" b="1" dirty="0">
+                <a:solidFill>
+                  <a:srgbClr val="B85042"/>
+                </a:solidFill>
+                <a:latin typeface="Georgia" pitchFamily="34" charset="0"/>
+                <a:ea typeface="Georgia" pitchFamily="34" charset="-122"/>
+                <a:cs typeface="Georgia" pitchFamily="34" charset="-120"/>
+              </a:rPr>
+              <a:t>”</a:t>
+            </a:r>
+            <a:pPr indent="0" marL="0">
+              <a:buNone/>
+            </a:pPr>
+            <a:r>
+              <a:rPr lang="en-US" sz="1300" dirty="0">
+                <a:solidFill>
+                  <a:srgbClr val="7A4F47"/>
+                </a:solidFill>
+                <a:latin typeface="Georgia" pitchFamily="34" charset="0"/>
+                <a:ea typeface="Georgia" pitchFamily="34" charset="-122"/>
+                <a:cs typeface="Georgia" pitchFamily="34" charset="-120"/>
+              </a:rPr>
+              <a:t>   — my Paynow MD, on why this project exists.</a:t>
+            </a:r>
+            <a:endParaRPr lang="en-US" sz="1400" dirty="0"/>
+          </a:p>
+        </p:txBody>
+      </p:sp>
+      <p:sp>
+        <p:nvSpPr>
+          <p:cNvPr id="17" name="Text 15"/>
           <p:cNvSpPr/>
           <p:nvPr/>
         </p:nvSpPr>
@@ -4045,7 +4126,7 @@
       </p:sp>
       <p:sp>
         <p:nvSpPr>
-          <p:cNvPr id="17" name="Text 15"/>
+          <p:cNvPr id="18" name="Text 16"/>
           <p:cNvSpPr/>
           <p:nvPr/>
         </p:nvSpPr>

</xml_diff>